<commit_message>
Add sale feedback UI and adjust economy
UI: Add sale feedback and gold-gain labels with animated tweens, update node hierarchy and label fonts/sizes in main_screen.tscn, and adjust main_screen.gd to show SOLD/NO SALE feedback and gain popups. Gameplay: shorten phase duration (180s -> 30s) and keep sell interval at 1s. Game logic: update potion demand values and change sale chance calculations to scale by price (reduce sensitivity) and cap maximum chance (0.95 / 95%). Misc: remove temporary ~$Scene_flow.pptx and update Scene_flow.pptx binary.
</commit_message>
<xml_diff>
--- a/Scene_flow.pptx
+++ b/Scene_flow.pptx
@@ -6,6 +6,7 @@
   </p:sldMasterIdLst>
   <p:sldIdLst>
     <p:sldId id="256" r:id="rId2"/>
+    <p:sldId id="257" r:id="rId3"/>
   </p:sldIdLst>
   <p:sldSz cx="12192000" cy="6858000"/>
   <p:notesSz cx="6858000" cy="9144000"/>
@@ -104,6 +105,11 @@
       </a:defRPr>
     </a:lvl9pPr>
   </p:defaultTextStyle>
+  <p:extLst>
+    <p:ext uri="{EFAFB233-063F-42B5-8137-9DF3F51BA10A}">
+      <p15:sldGuideLst xmlns:p15="http://schemas.microsoft.com/office/powerpoint/2012/main"/>
+    </p:ext>
+  </p:extLst>
 </p:presentation>
 </file>
 
@@ -553,6 +559,116 @@
 </inkml:ink>
 </file>
 
+<file path=ppt/ink/ink24.xml><?xml version="1.0" encoding="utf-8"?>
+<inkml:ink xmlns:inkml="http://www.w3.org/2003/InkML">
+  <inkml:definitions>
+    <inkml:context xml:id="ctx0">
+      <inkml:inkSource xml:id="inkSrc0">
+        <inkml:traceFormat>
+          <inkml:channel name="X" type="integer" min="-2.14748E9" max="2.14748E9" units="cm"/>
+          <inkml:channel name="Y" type="integer" min="-2.14748E9" max="2.14748E9" units="cm"/>
+          <inkml:channel name="F" type="integer" max="32767" units="dev"/>
+        </inkml:traceFormat>
+        <inkml:channelProperties>
+          <inkml:channelProperty channel="X" name="resolution" value="1000" units="1/cm"/>
+          <inkml:channelProperty channel="Y" name="resolution" value="1000" units="1/cm"/>
+          <inkml:channelProperty channel="F" name="resolution" value="0" units="1/dev"/>
+        </inkml:channelProperties>
+      </inkml:inkSource>
+      <inkml:timestamp xml:id="ts0" timeString="2026-05-25T11:24:06.201"/>
+    </inkml:context>
+    <inkml:brush xml:id="br0">
+      <inkml:brushProperty name="width" value="0.035" units="cm"/>
+      <inkml:brushProperty name="height" value="0.035" units="cm"/>
+    </inkml:brush>
+  </inkml:definitions>
+  <inkml:trace contextRef="#ctx0" brushRef="#br0">0 0 24575,'0'3'0,"0"-1"0</inkml:trace>
+</inkml:ink>
+</file>
+
+<file path=ppt/ink/ink25.xml><?xml version="1.0" encoding="utf-8"?>
+<inkml:ink xmlns:inkml="http://www.w3.org/2003/InkML">
+  <inkml:definitions>
+    <inkml:context xml:id="ctx0">
+      <inkml:inkSource xml:id="inkSrc0">
+        <inkml:traceFormat>
+          <inkml:channel name="X" type="integer" min="-2.14748E9" max="2.14748E9" units="cm"/>
+          <inkml:channel name="Y" type="integer" min="-2.14748E9" max="2.14748E9" units="cm"/>
+          <inkml:channel name="F" type="integer" max="32767" units="dev"/>
+        </inkml:traceFormat>
+        <inkml:channelProperties>
+          <inkml:channelProperty channel="X" name="resolution" value="1000" units="1/cm"/>
+          <inkml:channelProperty channel="Y" name="resolution" value="1000" units="1/cm"/>
+          <inkml:channelProperty channel="F" name="resolution" value="0" units="1/dev"/>
+        </inkml:channelProperties>
+      </inkml:inkSource>
+      <inkml:timestamp xml:id="ts0" timeString="2026-05-25T11:24:05.017"/>
+    </inkml:context>
+    <inkml:brush xml:id="br0">
+      <inkml:brushProperty name="width" value="0.035" units="cm"/>
+      <inkml:brushProperty name="height" value="0.035" units="cm"/>
+    </inkml:brush>
+  </inkml:definitions>
+  <inkml:trace contextRef="#ctx0" brushRef="#br0">1 1 23036,'3'2'0,"-1"0"0</inkml:trace>
+</inkml:ink>
+</file>
+
+<file path=ppt/ink/ink26.xml><?xml version="1.0" encoding="utf-8"?>
+<inkml:ink xmlns:inkml="http://www.w3.org/2003/InkML">
+  <inkml:definitions>
+    <inkml:context xml:id="ctx0">
+      <inkml:inkSource xml:id="inkSrc0">
+        <inkml:traceFormat>
+          <inkml:channel name="X" type="integer" min="-2.14748E9" max="2.14748E9" units="cm"/>
+          <inkml:channel name="Y" type="integer" min="-2.14748E9" max="2.14748E9" units="cm"/>
+          <inkml:channel name="F" type="integer" max="32767" units="dev"/>
+        </inkml:traceFormat>
+        <inkml:channelProperties>
+          <inkml:channelProperty channel="X" name="resolution" value="1000" units="1/cm"/>
+          <inkml:channelProperty channel="Y" name="resolution" value="1000" units="1/cm"/>
+          <inkml:channelProperty channel="F" name="resolution" value="0" units="1/dev"/>
+        </inkml:channelProperties>
+      </inkml:inkSource>
+      <inkml:timestamp xml:id="ts0" timeString="2026-05-25T11:27:56.983"/>
+    </inkml:context>
+    <inkml:brush xml:id="br0">
+      <inkml:brushProperty name="width" value="0.035" units="cm"/>
+      <inkml:brushProperty name="height" value="0.035" units="cm"/>
+      <inkml:brushProperty name="color" value="#008C3A"/>
+    </inkml:brush>
+  </inkml:definitions>
+  <inkml:trace contextRef="#ctx0" brushRef="#br0">1 1 24575,'2'6'0,"1"-2"0</inkml:trace>
+</inkml:ink>
+</file>
+
+<file path=ppt/ink/ink27.xml><?xml version="1.0" encoding="utf-8"?>
+<inkml:ink xmlns:inkml="http://www.w3.org/2003/InkML">
+  <inkml:definitions>
+    <inkml:context xml:id="ctx0">
+      <inkml:inkSource xml:id="inkSrc0">
+        <inkml:traceFormat>
+          <inkml:channel name="X" type="integer" min="-2.14748E9" max="2.14748E9" units="cm"/>
+          <inkml:channel name="Y" type="integer" min="-2.14748E9" max="2.14748E9" units="cm"/>
+          <inkml:channel name="F" type="integer" max="32767" units="dev"/>
+        </inkml:traceFormat>
+        <inkml:channelProperties>
+          <inkml:channelProperty channel="X" name="resolution" value="1000" units="1/cm"/>
+          <inkml:channelProperty channel="Y" name="resolution" value="1000" units="1/cm"/>
+          <inkml:channelProperty channel="F" name="resolution" value="0" units="1/dev"/>
+        </inkml:channelProperties>
+      </inkml:inkSource>
+      <inkml:timestamp xml:id="ts0" timeString="2026-05-25T11:47:08.338"/>
+    </inkml:context>
+    <inkml:brush xml:id="br0">
+      <inkml:brushProperty name="width" value="0.025" units="cm"/>
+      <inkml:brushProperty name="height" value="0.025" units="cm"/>
+      <inkml:brushProperty name="color" value="#E71224"/>
+    </inkml:brush>
+  </inkml:definitions>
+  <inkml:trace contextRef="#ctx0" brushRef="#br0">0 0 24575,'2'1'0,"-1"0"0</inkml:trace>
+</inkml:ink>
+</file>
+
 <file path=ppt/ink/ink3.xml><?xml version="1.0" encoding="utf-8"?>
 <inkml:ink xmlns:inkml="http://www.w3.org/2003/InkML">
   <inkml:definitions>
@@ -892,7 +1008,7 @@
           <a:p>
             <a:fld id="{E8BA11E2-D1EF-2F40-9EDA-A7C9F8BCD333}" type="datetimeFigureOut">
               <a:rPr lang="en-US" smtClean="0"/>
-              <a:t>5/25/26</a:t>
+              <a:t>5/26/26</a:t>
             </a:fld>
             <a:endParaRPr lang="en-US"/>
           </a:p>
@@ -1092,7 +1208,7 @@
           <a:p>
             <a:fld id="{E8BA11E2-D1EF-2F40-9EDA-A7C9F8BCD333}" type="datetimeFigureOut">
               <a:rPr lang="en-US" smtClean="0"/>
-              <a:t>5/25/26</a:t>
+              <a:t>5/26/26</a:t>
             </a:fld>
             <a:endParaRPr lang="en-US"/>
           </a:p>
@@ -1302,7 +1418,7 @@
           <a:p>
             <a:fld id="{E8BA11E2-D1EF-2F40-9EDA-A7C9F8BCD333}" type="datetimeFigureOut">
               <a:rPr lang="en-US" smtClean="0"/>
-              <a:t>5/25/26</a:t>
+              <a:t>5/26/26</a:t>
             </a:fld>
             <a:endParaRPr lang="en-US"/>
           </a:p>
@@ -1502,7 +1618,7 @@
           <a:p>
             <a:fld id="{E8BA11E2-D1EF-2F40-9EDA-A7C9F8BCD333}" type="datetimeFigureOut">
               <a:rPr lang="en-US" smtClean="0"/>
-              <a:t>5/25/26</a:t>
+              <a:t>5/26/26</a:t>
             </a:fld>
             <a:endParaRPr lang="en-US"/>
           </a:p>
@@ -1778,7 +1894,7 @@
           <a:p>
             <a:fld id="{E8BA11E2-D1EF-2F40-9EDA-A7C9F8BCD333}" type="datetimeFigureOut">
               <a:rPr lang="en-US" smtClean="0"/>
-              <a:t>5/25/26</a:t>
+              <a:t>5/26/26</a:t>
             </a:fld>
             <a:endParaRPr lang="en-US"/>
           </a:p>
@@ -2046,7 +2162,7 @@
           <a:p>
             <a:fld id="{E8BA11E2-D1EF-2F40-9EDA-A7C9F8BCD333}" type="datetimeFigureOut">
               <a:rPr lang="en-US" smtClean="0"/>
-              <a:t>5/25/26</a:t>
+              <a:t>5/26/26</a:t>
             </a:fld>
             <a:endParaRPr lang="en-US"/>
           </a:p>
@@ -2461,7 +2577,7 @@
           <a:p>
             <a:fld id="{E8BA11E2-D1EF-2F40-9EDA-A7C9F8BCD333}" type="datetimeFigureOut">
               <a:rPr lang="en-US" smtClean="0"/>
-              <a:t>5/25/26</a:t>
+              <a:t>5/26/26</a:t>
             </a:fld>
             <a:endParaRPr lang="en-US"/>
           </a:p>
@@ -2603,7 +2719,7 @@
           <a:p>
             <a:fld id="{E8BA11E2-D1EF-2F40-9EDA-A7C9F8BCD333}" type="datetimeFigureOut">
               <a:rPr lang="en-US" smtClean="0"/>
-              <a:t>5/25/26</a:t>
+              <a:t>5/26/26</a:t>
             </a:fld>
             <a:endParaRPr lang="en-US"/>
           </a:p>
@@ -2716,7 +2832,7 @@
           <a:p>
             <a:fld id="{E8BA11E2-D1EF-2F40-9EDA-A7C9F8BCD333}" type="datetimeFigureOut">
               <a:rPr lang="en-US" smtClean="0"/>
-              <a:t>5/25/26</a:t>
+              <a:t>5/26/26</a:t>
             </a:fld>
             <a:endParaRPr lang="en-US"/>
           </a:p>
@@ -3029,7 +3145,7 @@
           <a:p>
             <a:fld id="{E8BA11E2-D1EF-2F40-9EDA-A7C9F8BCD333}" type="datetimeFigureOut">
               <a:rPr lang="en-US" smtClean="0"/>
-              <a:t>5/25/26</a:t>
+              <a:t>5/26/26</a:t>
             </a:fld>
             <a:endParaRPr lang="en-US"/>
           </a:p>
@@ -3318,7 +3434,7 @@
           <a:p>
             <a:fld id="{E8BA11E2-D1EF-2F40-9EDA-A7C9F8BCD333}" type="datetimeFigureOut">
               <a:rPr lang="en-US" smtClean="0"/>
-              <a:t>5/25/26</a:t>
+              <a:t>5/26/26</a:t>
             </a:fld>
             <a:endParaRPr lang="en-US"/>
           </a:p>
@@ -3561,7 +3677,7 @@
           <a:p>
             <a:fld id="{E8BA11E2-D1EF-2F40-9EDA-A7C9F8BCD333}" type="datetimeFigureOut">
               <a:rPr lang="en-US" smtClean="0"/>
-              <a:t>5/25/26</a:t>
+              <a:t>5/26/26</a:t>
             </a:fld>
             <a:endParaRPr lang="en-US"/>
           </a:p>
@@ -4068,8 +4184,8 @@
           </a:prstGeom>
         </p:spPr>
       </p:pic>
-      <mc:AlternateContent xmlns:mc="http://schemas.openxmlformats.org/markup-compatibility/2006">
-        <mc:Choice xmlns:p14="http://schemas.microsoft.com/office/powerpoint/2010/main" Requires="p14">
+      <mc:AlternateContent xmlns:mc="http://schemas.openxmlformats.org/markup-compatibility/2006" xmlns:p14="http://schemas.microsoft.com/office/powerpoint/2010/main">
+        <mc:Choice Requires="p14">
           <p:contentPart p14:bwMode="auto" r:id="rId5">
             <p14:nvContentPartPr>
               <p14:cNvPr id="7" name="Ink 6">
@@ -4088,7 +4204,7 @@
             </p14:xfrm>
           </p:contentPart>
         </mc:Choice>
-        <mc:Fallback>
+        <mc:Fallback xmlns="">
           <p:pic>
             <p:nvPicPr>
               <p:cNvPr id="7" name="Ink 6">
@@ -4119,8 +4235,8 @@
           </p:pic>
         </mc:Fallback>
       </mc:AlternateContent>
-      <mc:AlternateContent xmlns:mc="http://schemas.openxmlformats.org/markup-compatibility/2006">
-        <mc:Choice xmlns:p14="http://schemas.microsoft.com/office/powerpoint/2010/main" Requires="p14">
+      <mc:AlternateContent xmlns:mc="http://schemas.openxmlformats.org/markup-compatibility/2006" xmlns:p14="http://schemas.microsoft.com/office/powerpoint/2010/main">
+        <mc:Choice Requires="p14">
           <p:contentPart p14:bwMode="auto" r:id="rId7">
             <p14:nvContentPartPr>
               <p14:cNvPr id="8" name="Ink 7">
@@ -4139,7 +4255,7 @@
             </p14:xfrm>
           </p:contentPart>
         </mc:Choice>
-        <mc:Fallback>
+        <mc:Fallback xmlns="">
           <p:pic>
             <p:nvPicPr>
               <p:cNvPr id="8" name="Ink 7">
@@ -4170,8 +4286,8 @@
           </p:pic>
         </mc:Fallback>
       </mc:AlternateContent>
-      <mc:AlternateContent xmlns:mc="http://schemas.openxmlformats.org/markup-compatibility/2006">
-        <mc:Choice xmlns:p14="http://schemas.microsoft.com/office/powerpoint/2010/main" Requires="p14">
+      <mc:AlternateContent xmlns:mc="http://schemas.openxmlformats.org/markup-compatibility/2006" xmlns:p14="http://schemas.microsoft.com/office/powerpoint/2010/main">
+        <mc:Choice Requires="p14">
           <p:contentPart p14:bwMode="auto" r:id="rId9">
             <p14:nvContentPartPr>
               <p14:cNvPr id="36" name="Ink 35">
@@ -4190,7 +4306,7 @@
             </p14:xfrm>
           </p:contentPart>
         </mc:Choice>
-        <mc:Fallback>
+        <mc:Fallback xmlns="">
           <p:pic>
             <p:nvPicPr>
               <p:cNvPr id="36" name="Ink 35">
@@ -4221,8 +4337,8 @@
           </p:pic>
         </mc:Fallback>
       </mc:AlternateContent>
-      <mc:AlternateContent xmlns:mc="http://schemas.openxmlformats.org/markup-compatibility/2006">
-        <mc:Choice xmlns:p14="http://schemas.microsoft.com/office/powerpoint/2010/main" Requires="p14">
+      <mc:AlternateContent xmlns:mc="http://schemas.openxmlformats.org/markup-compatibility/2006" xmlns:p14="http://schemas.microsoft.com/office/powerpoint/2010/main">
+        <mc:Choice Requires="p14">
           <p:contentPart p14:bwMode="auto" r:id="rId11">
             <p14:nvContentPartPr>
               <p14:cNvPr id="37" name="Ink 36">
@@ -4241,7 +4357,7 @@
             </p14:xfrm>
           </p:contentPart>
         </mc:Choice>
-        <mc:Fallback>
+        <mc:Fallback xmlns="">
           <p:pic>
             <p:nvPicPr>
               <p:cNvPr id="37" name="Ink 36">
@@ -4332,8 +4448,8 @@
           </a:prstGeom>
         </p:spPr>
       </p:pic>
-      <mc:AlternateContent xmlns:mc="http://schemas.openxmlformats.org/markup-compatibility/2006">
-        <mc:Choice xmlns:p14="http://schemas.microsoft.com/office/powerpoint/2010/main" Requires="p14">
+      <mc:AlternateContent xmlns:mc="http://schemas.openxmlformats.org/markup-compatibility/2006" xmlns:p14="http://schemas.microsoft.com/office/powerpoint/2010/main">
+        <mc:Choice Requires="p14">
           <p:contentPart p14:bwMode="auto" r:id="rId15">
             <p14:nvContentPartPr>
               <p14:cNvPr id="19" name="Ink 18">
@@ -4352,7 +4468,7 @@
             </p14:xfrm>
           </p:contentPart>
         </mc:Choice>
-        <mc:Fallback>
+        <mc:Fallback xmlns="">
           <p:pic>
             <p:nvPicPr>
               <p:cNvPr id="19" name="Ink 18">
@@ -4383,8 +4499,8 @@
           </p:pic>
         </mc:Fallback>
       </mc:AlternateContent>
-      <mc:AlternateContent xmlns:mc="http://schemas.openxmlformats.org/markup-compatibility/2006">
-        <mc:Choice xmlns:p14="http://schemas.microsoft.com/office/powerpoint/2010/main" Requires="p14">
+      <mc:AlternateContent xmlns:mc="http://schemas.openxmlformats.org/markup-compatibility/2006" xmlns:p14="http://schemas.microsoft.com/office/powerpoint/2010/main">
+        <mc:Choice Requires="p14">
           <p:contentPart p14:bwMode="auto" r:id="rId17">
             <p14:nvContentPartPr>
               <p14:cNvPr id="21" name="Ink 20">
@@ -4403,7 +4519,7 @@
             </p14:xfrm>
           </p:contentPart>
         </mc:Choice>
-        <mc:Fallback>
+        <mc:Fallback xmlns="">
           <p:pic>
             <p:nvPicPr>
               <p:cNvPr id="21" name="Ink 20">
@@ -4434,8 +4550,8 @@
           </p:pic>
         </mc:Fallback>
       </mc:AlternateContent>
-      <mc:AlternateContent xmlns:mc="http://schemas.openxmlformats.org/markup-compatibility/2006">
-        <mc:Choice xmlns:p14="http://schemas.microsoft.com/office/powerpoint/2010/main" Requires="p14">
+      <mc:AlternateContent xmlns:mc="http://schemas.openxmlformats.org/markup-compatibility/2006" xmlns:p14="http://schemas.microsoft.com/office/powerpoint/2010/main">
+        <mc:Choice Requires="p14">
           <p:contentPart p14:bwMode="auto" r:id="rId19">
             <p14:nvContentPartPr>
               <p14:cNvPr id="31" name="Ink 30">
@@ -4454,7 +4570,7 @@
             </p14:xfrm>
           </p:contentPart>
         </mc:Choice>
-        <mc:Fallback>
+        <mc:Fallback xmlns="">
           <p:pic>
             <p:nvPicPr>
               <p:cNvPr id="31" name="Ink 30">
@@ -4485,8 +4601,8 @@
           </p:pic>
         </mc:Fallback>
       </mc:AlternateContent>
-      <mc:AlternateContent xmlns:mc="http://schemas.openxmlformats.org/markup-compatibility/2006">
-        <mc:Choice xmlns:p14="http://schemas.microsoft.com/office/powerpoint/2010/main" Requires="p14">
+      <mc:AlternateContent xmlns:mc="http://schemas.openxmlformats.org/markup-compatibility/2006" xmlns:p14="http://schemas.microsoft.com/office/powerpoint/2010/main">
+        <mc:Choice Requires="p14">
           <p:contentPart p14:bwMode="auto" r:id="rId21">
             <p14:nvContentPartPr>
               <p14:cNvPr id="35" name="Ink 34">
@@ -4505,7 +4621,7 @@
             </p14:xfrm>
           </p:contentPart>
         </mc:Choice>
-        <mc:Fallback>
+        <mc:Fallback xmlns="">
           <p:pic>
             <p:nvPicPr>
               <p:cNvPr id="35" name="Ink 34">
@@ -4536,8 +4652,8 @@
           </p:pic>
         </mc:Fallback>
       </mc:AlternateContent>
-      <mc:AlternateContent xmlns:mc="http://schemas.openxmlformats.org/markup-compatibility/2006">
-        <mc:Choice xmlns:p14="http://schemas.microsoft.com/office/powerpoint/2010/main" Requires="p14">
+      <mc:AlternateContent xmlns:mc="http://schemas.openxmlformats.org/markup-compatibility/2006" xmlns:p14="http://schemas.microsoft.com/office/powerpoint/2010/main">
+        <mc:Choice Requires="p14">
           <p:contentPart p14:bwMode="auto" r:id="rId22">
             <p14:nvContentPartPr>
               <p14:cNvPr id="45" name="Ink 44">
@@ -4556,7 +4672,7 @@
             </p14:xfrm>
           </p:contentPart>
         </mc:Choice>
-        <mc:Fallback>
+        <mc:Fallback xmlns="">
           <p:pic>
             <p:nvPicPr>
               <p:cNvPr id="45" name="Ink 44">
@@ -4647,8 +4763,8 @@
           </a:prstGeom>
         </p:spPr>
       </p:pic>
-      <mc:AlternateContent xmlns:mc="http://schemas.openxmlformats.org/markup-compatibility/2006">
-        <mc:Choice xmlns:p14="http://schemas.microsoft.com/office/powerpoint/2010/main" Requires="p14">
+      <mc:AlternateContent xmlns:mc="http://schemas.openxmlformats.org/markup-compatibility/2006" xmlns:p14="http://schemas.microsoft.com/office/powerpoint/2010/main">
+        <mc:Choice Requires="p14">
           <p:contentPart p14:bwMode="auto" r:id="rId26">
             <p14:nvContentPartPr>
               <p14:cNvPr id="65" name="Ink 64">
@@ -4667,7 +4783,7 @@
             </p14:xfrm>
           </p:contentPart>
         </mc:Choice>
-        <mc:Fallback>
+        <mc:Fallback xmlns="">
           <p:pic>
             <p:nvPicPr>
               <p:cNvPr id="65" name="Ink 64">
@@ -4718,8 +4834,8 @@
             <a:chExt cx="1676160" cy="415440"/>
           </a:xfrm>
         </p:grpSpPr>
-        <mc:AlternateContent xmlns:mc="http://schemas.openxmlformats.org/markup-compatibility/2006">
-          <mc:Choice xmlns:p14="http://schemas.microsoft.com/office/powerpoint/2010/main" Requires="p14">
+        <mc:AlternateContent xmlns:mc="http://schemas.openxmlformats.org/markup-compatibility/2006" xmlns:p14="http://schemas.microsoft.com/office/powerpoint/2010/main">
+          <mc:Choice Requires="p14">
             <p:contentPart p14:bwMode="auto" r:id="rId28">
               <p14:nvContentPartPr>
                 <p14:cNvPr id="66" name="Ink 65">
@@ -4738,7 +4854,7 @@
               </p14:xfrm>
             </p:contentPart>
           </mc:Choice>
-          <mc:Fallback>
+          <mc:Fallback xmlns="">
             <p:pic>
               <p:nvPicPr>
                 <p:cNvPr id="66" name="Ink 65">
@@ -4769,8 +4885,8 @@
             </p:pic>
           </mc:Fallback>
         </mc:AlternateContent>
-        <mc:AlternateContent xmlns:mc="http://schemas.openxmlformats.org/markup-compatibility/2006">
-          <mc:Choice xmlns:p14="http://schemas.microsoft.com/office/powerpoint/2010/main" Requires="p14">
+        <mc:AlternateContent xmlns:mc="http://schemas.openxmlformats.org/markup-compatibility/2006" xmlns:p14="http://schemas.microsoft.com/office/powerpoint/2010/main">
+          <mc:Choice Requires="p14">
             <p:contentPart p14:bwMode="auto" r:id="rId30">
               <p14:nvContentPartPr>
                 <p14:cNvPr id="67" name="Ink 66">
@@ -4789,7 +4905,7 @@
               </p14:xfrm>
             </p:contentPart>
           </mc:Choice>
-          <mc:Fallback>
+          <mc:Fallback xmlns="">
             <p:pic>
               <p:nvPicPr>
                 <p:cNvPr id="67" name="Ink 66">
@@ -4821,8 +4937,8 @@
           </mc:Fallback>
         </mc:AlternateContent>
       </p:grpSp>
-      <mc:AlternateContent xmlns:mc="http://schemas.openxmlformats.org/markup-compatibility/2006">
-        <mc:Choice xmlns:p14="http://schemas.microsoft.com/office/powerpoint/2010/main" Requires="p14">
+      <mc:AlternateContent xmlns:mc="http://schemas.openxmlformats.org/markup-compatibility/2006" xmlns:p14="http://schemas.microsoft.com/office/powerpoint/2010/main">
+        <mc:Choice Requires="p14">
           <p:contentPart p14:bwMode="auto" r:id="rId32">
             <p14:nvContentPartPr>
               <p14:cNvPr id="70" name="Ink 69">
@@ -4841,7 +4957,7 @@
             </p14:xfrm>
           </p:contentPart>
         </mc:Choice>
-        <mc:Fallback>
+        <mc:Fallback xmlns="">
           <p:pic>
             <p:nvPicPr>
               <p:cNvPr id="70" name="Ink 69">
@@ -4872,8 +4988,8 @@
           </p:pic>
         </mc:Fallback>
       </mc:AlternateContent>
-      <mc:AlternateContent xmlns:mc="http://schemas.openxmlformats.org/markup-compatibility/2006">
-        <mc:Choice xmlns:p14="http://schemas.microsoft.com/office/powerpoint/2010/main" Requires="p14">
+      <mc:AlternateContent xmlns:mc="http://schemas.openxmlformats.org/markup-compatibility/2006" xmlns:p14="http://schemas.microsoft.com/office/powerpoint/2010/main">
+        <mc:Choice Requires="p14">
           <p:contentPart p14:bwMode="auto" r:id="rId34">
             <p14:nvContentPartPr>
               <p14:cNvPr id="74" name="Ink 73">
@@ -4892,7 +5008,7 @@
             </p14:xfrm>
           </p:contentPart>
         </mc:Choice>
-        <mc:Fallback>
+        <mc:Fallback xmlns="">
           <p:pic>
             <p:nvPicPr>
               <p:cNvPr id="74" name="Ink 73">
@@ -4923,8 +5039,8 @@
           </p:pic>
         </mc:Fallback>
       </mc:AlternateContent>
-      <mc:AlternateContent xmlns:mc="http://schemas.openxmlformats.org/markup-compatibility/2006">
-        <mc:Choice xmlns:p14="http://schemas.microsoft.com/office/powerpoint/2010/main" Requires="p14">
+      <mc:AlternateContent xmlns:mc="http://schemas.openxmlformats.org/markup-compatibility/2006" xmlns:p14="http://schemas.microsoft.com/office/powerpoint/2010/main">
+        <mc:Choice Requires="p14">
           <p:contentPart p14:bwMode="auto" r:id="rId36">
             <p14:nvContentPartPr>
               <p14:cNvPr id="81" name="Ink 80">
@@ -4943,7 +5059,7 @@
             </p14:xfrm>
           </p:contentPart>
         </mc:Choice>
-        <mc:Fallback>
+        <mc:Fallback xmlns="">
           <p:pic>
             <p:nvPicPr>
               <p:cNvPr id="81" name="Ink 80">
@@ -4974,8 +5090,8 @@
           </p:pic>
         </mc:Fallback>
       </mc:AlternateContent>
-      <mc:AlternateContent xmlns:mc="http://schemas.openxmlformats.org/markup-compatibility/2006">
-        <mc:Choice xmlns:p14="http://schemas.microsoft.com/office/powerpoint/2010/main" Requires="p14">
+      <mc:AlternateContent xmlns:mc="http://schemas.openxmlformats.org/markup-compatibility/2006" xmlns:p14="http://schemas.microsoft.com/office/powerpoint/2010/main">
+        <mc:Choice Requires="p14">
           <p:contentPart p14:bwMode="auto" r:id="rId38">
             <p14:nvContentPartPr>
               <p14:cNvPr id="82" name="Ink 81">
@@ -4994,7 +5110,7 @@
             </p14:xfrm>
           </p:contentPart>
         </mc:Choice>
-        <mc:Fallback>
+        <mc:Fallback xmlns="">
           <p:pic>
             <p:nvPicPr>
               <p:cNvPr id="82" name="Ink 81">
@@ -5025,8 +5141,8 @@
           </p:pic>
         </mc:Fallback>
       </mc:AlternateContent>
-      <mc:AlternateContent xmlns:mc="http://schemas.openxmlformats.org/markup-compatibility/2006">
-        <mc:Choice xmlns:p14="http://schemas.microsoft.com/office/powerpoint/2010/main" Requires="p14">
+      <mc:AlternateContent xmlns:mc="http://schemas.openxmlformats.org/markup-compatibility/2006" xmlns:p14="http://schemas.microsoft.com/office/powerpoint/2010/main">
+        <mc:Choice Requires="p14">
           <p:contentPart p14:bwMode="auto" r:id="rId40">
             <p14:nvContentPartPr>
               <p14:cNvPr id="83" name="Ink 82">
@@ -5045,7 +5161,7 @@
             </p14:xfrm>
           </p:contentPart>
         </mc:Choice>
-        <mc:Fallback>
+        <mc:Fallback xmlns="">
           <p:pic>
             <p:nvPicPr>
               <p:cNvPr id="83" name="Ink 82">
@@ -5076,8 +5192,8 @@
           </p:pic>
         </mc:Fallback>
       </mc:AlternateContent>
-      <mc:AlternateContent xmlns:mc="http://schemas.openxmlformats.org/markup-compatibility/2006">
-        <mc:Choice xmlns:p14="http://schemas.microsoft.com/office/powerpoint/2010/main" Requires="p14">
+      <mc:AlternateContent xmlns:mc="http://schemas.openxmlformats.org/markup-compatibility/2006" xmlns:p14="http://schemas.microsoft.com/office/powerpoint/2010/main">
+        <mc:Choice Requires="p14">
           <p:contentPart p14:bwMode="auto" r:id="rId42">
             <p14:nvContentPartPr>
               <p14:cNvPr id="88" name="Ink 87">
@@ -5096,7 +5212,7 @@
             </p14:xfrm>
           </p:contentPart>
         </mc:Choice>
-        <mc:Fallback>
+        <mc:Fallback xmlns="">
           <p:pic>
             <p:nvPicPr>
               <p:cNvPr id="88" name="Ink 87">
@@ -5162,8 +5278,8 @@
           </a:p>
         </p:txBody>
       </p:sp>
-      <mc:AlternateContent xmlns:mc="http://schemas.openxmlformats.org/markup-compatibility/2006">
-        <mc:Choice xmlns:p14="http://schemas.microsoft.com/office/powerpoint/2010/main" Requires="p14">
+      <mc:AlternateContent xmlns:mc="http://schemas.openxmlformats.org/markup-compatibility/2006" xmlns:p14="http://schemas.microsoft.com/office/powerpoint/2010/main">
+        <mc:Choice Requires="p14">
           <p:contentPart p14:bwMode="auto" r:id="rId44">
             <p14:nvContentPartPr>
               <p14:cNvPr id="90" name="Ink 89">
@@ -5182,7 +5298,7 @@
             </p14:xfrm>
           </p:contentPart>
         </mc:Choice>
-        <mc:Fallback>
+        <mc:Fallback xmlns="">
           <p:pic>
             <p:nvPicPr>
               <p:cNvPr id="90" name="Ink 89">
@@ -5213,8 +5329,8 @@
           </p:pic>
         </mc:Fallback>
       </mc:AlternateContent>
-      <mc:AlternateContent xmlns:mc="http://schemas.openxmlformats.org/markup-compatibility/2006">
-        <mc:Choice xmlns:p14="http://schemas.microsoft.com/office/powerpoint/2010/main" Requires="p14">
+      <mc:AlternateContent xmlns:mc="http://schemas.openxmlformats.org/markup-compatibility/2006" xmlns:p14="http://schemas.microsoft.com/office/powerpoint/2010/main">
+        <mc:Choice Requires="p14">
           <p:contentPart p14:bwMode="auto" r:id="rId46">
             <p14:nvContentPartPr>
               <p14:cNvPr id="91" name="Ink 90">
@@ -5233,7 +5349,7 @@
             </p14:xfrm>
           </p:contentPart>
         </mc:Choice>
-        <mc:Fallback>
+        <mc:Fallback xmlns="">
           <p:pic>
             <p:nvPicPr>
               <p:cNvPr id="91" name="Ink 90">
@@ -5299,8 +5415,8 @@
           </a:p>
         </p:txBody>
       </p:sp>
-      <mc:AlternateContent xmlns:mc="http://schemas.openxmlformats.org/markup-compatibility/2006">
-        <mc:Choice xmlns:p14="http://schemas.microsoft.com/office/powerpoint/2010/main" Requires="p14">
+      <mc:AlternateContent xmlns:mc="http://schemas.openxmlformats.org/markup-compatibility/2006" xmlns:p14="http://schemas.microsoft.com/office/powerpoint/2010/main">
+        <mc:Choice Requires="p14">
           <p:contentPart p14:bwMode="auto" r:id="rId48">
             <p14:nvContentPartPr>
               <p14:cNvPr id="93" name="Ink 92">
@@ -5319,7 +5435,7 @@
             </p14:xfrm>
           </p:contentPart>
         </mc:Choice>
-        <mc:Fallback>
+        <mc:Fallback xmlns="">
           <p:pic>
             <p:nvPicPr>
               <p:cNvPr id="93" name="Ink 92">
@@ -5386,8 +5502,8 @@
           </a:p>
         </p:txBody>
       </p:sp>
-      <mc:AlternateContent xmlns:mc="http://schemas.openxmlformats.org/markup-compatibility/2006">
-        <mc:Choice xmlns:p14="http://schemas.microsoft.com/office/powerpoint/2010/main" Requires="p14">
+      <mc:AlternateContent xmlns:mc="http://schemas.openxmlformats.org/markup-compatibility/2006" xmlns:p14="http://schemas.microsoft.com/office/powerpoint/2010/main">
+        <mc:Choice Requires="p14">
           <p:contentPart p14:bwMode="auto" r:id="rId50">
             <p14:nvContentPartPr>
               <p14:cNvPr id="95" name="Ink 94">
@@ -5406,7 +5522,7 @@
             </p14:xfrm>
           </p:contentPart>
         </mc:Choice>
-        <mc:Fallback>
+        <mc:Fallback xmlns="">
           <p:pic>
             <p:nvPicPr>
               <p:cNvPr id="95" name="Ink 94">
@@ -5473,8 +5589,8 @@
           </a:p>
         </p:txBody>
       </p:sp>
-      <mc:AlternateContent xmlns:mc="http://schemas.openxmlformats.org/markup-compatibility/2006">
-        <mc:Choice xmlns:p14="http://schemas.microsoft.com/office/powerpoint/2010/main" Requires="p14">
+      <mc:AlternateContent xmlns:mc="http://schemas.openxmlformats.org/markup-compatibility/2006" xmlns:p14="http://schemas.microsoft.com/office/powerpoint/2010/main">
+        <mc:Choice Requires="p14">
           <p:contentPart p14:bwMode="auto" r:id="rId52">
             <p14:nvContentPartPr>
               <p14:cNvPr id="112" name="Ink 111">
@@ -5493,7 +5609,7 @@
             </p14:xfrm>
           </p:contentPart>
         </mc:Choice>
-        <mc:Fallback>
+        <mc:Fallback xmlns="">
           <p:pic>
             <p:nvPicPr>
               <p:cNvPr id="112" name="Ink 111">
@@ -5528,6 +5644,456 @@
     <p:extLst>
       <p:ext uri="{BB962C8B-B14F-4D97-AF65-F5344CB8AC3E}">
         <p14:creationId xmlns:p14="http://schemas.microsoft.com/office/powerpoint/2010/main" val="140697781"/>
+      </p:ext>
+    </p:extLst>
+  </p:cSld>
+  <p:clrMapOvr>
+    <a:masterClrMapping/>
+  </p:clrMapOvr>
+</p:sld>
+</file>
+
+<file path=ppt/slides/slide2.xml><?xml version="1.0" encoding="utf-8"?>
+<p:sld xmlns:a="http://schemas.openxmlformats.org/drawingml/2006/main" xmlns:r="http://schemas.openxmlformats.org/officeDocument/2006/relationships" xmlns:p="http://schemas.openxmlformats.org/presentationml/2006/main">
+  <p:cSld>
+    <p:spTree>
+      <p:nvGrpSpPr>
+        <p:cNvPr id="1" name="">
+          <a:extLst>
+            <a:ext uri="{FF2B5EF4-FFF2-40B4-BE49-F238E27FC236}">
+              <a16:creationId xmlns:a16="http://schemas.microsoft.com/office/drawing/2014/main" id="{B566DE95-3540-EE67-09FC-E70B1E04DCAD}"/>
+            </a:ext>
+          </a:extLst>
+        </p:cNvPr>
+        <p:cNvGrpSpPr/>
+        <p:nvPr/>
+      </p:nvGrpSpPr>
+      <p:grpSpPr>
+        <a:xfrm>
+          <a:off x="0" y="0"/>
+          <a:ext cx="0" cy="0"/>
+          <a:chOff x="0" y="0"/>
+          <a:chExt cx="0" cy="0"/>
+        </a:xfrm>
+      </p:grpSpPr>
+      <p:pic>
+        <p:nvPicPr>
+          <p:cNvPr id="33" name="Picture 32">
+            <a:extLst>
+              <a:ext uri="{FF2B5EF4-FFF2-40B4-BE49-F238E27FC236}">
+                <a16:creationId xmlns:a16="http://schemas.microsoft.com/office/drawing/2014/main" id="{C7BA4A8B-7C40-A98A-08E3-2D13D99785F5}"/>
+              </a:ext>
+            </a:extLst>
+          </p:cNvPr>
+          <p:cNvPicPr>
+            <a:picLocks noChangeAspect="1"/>
+          </p:cNvPicPr>
+          <p:nvPr/>
+        </p:nvPicPr>
+        <p:blipFill>
+          <a:blip r:embed="rId2"/>
+          <a:stretch>
+            <a:fillRect/>
+          </a:stretch>
+        </p:blipFill>
+        <p:spPr>
+          <a:xfrm>
+            <a:off x="4205738" y="4874590"/>
+            <a:ext cx="2718104" cy="1537231"/>
+          </a:xfrm>
+          <a:prstGeom prst="rect">
+            <a:avLst/>
+          </a:prstGeom>
+        </p:spPr>
+      </p:pic>
+      <p:pic>
+        <p:nvPicPr>
+          <p:cNvPr id="39" name="Picture 38">
+            <a:extLst>
+              <a:ext uri="{FF2B5EF4-FFF2-40B4-BE49-F238E27FC236}">
+                <a16:creationId xmlns:a16="http://schemas.microsoft.com/office/drawing/2014/main" id="{B04C269C-CE54-34F2-1006-C2F3938C00BA}"/>
+              </a:ext>
+            </a:extLst>
+          </p:cNvPr>
+          <p:cNvPicPr>
+            <a:picLocks noChangeAspect="1"/>
+          </p:cNvPicPr>
+          <p:nvPr/>
+        </p:nvPicPr>
+        <p:blipFill>
+          <a:blip r:embed="rId3"/>
+          <a:stretch>
+            <a:fillRect/>
+          </a:stretch>
+        </p:blipFill>
+        <p:spPr>
+          <a:xfrm>
+            <a:off x="8067997" y="3888562"/>
+            <a:ext cx="3498291" cy="1972056"/>
+          </a:xfrm>
+          <a:prstGeom prst="rect">
+            <a:avLst/>
+          </a:prstGeom>
+        </p:spPr>
+      </p:pic>
+      <p:pic>
+        <p:nvPicPr>
+          <p:cNvPr id="5" name="Picture 4">
+            <a:extLst>
+              <a:ext uri="{FF2B5EF4-FFF2-40B4-BE49-F238E27FC236}">
+                <a16:creationId xmlns:a16="http://schemas.microsoft.com/office/drawing/2014/main" id="{53E85CAA-1F45-26D7-13BC-61CBC46B94F3}"/>
+              </a:ext>
+            </a:extLst>
+          </p:cNvPr>
+          <p:cNvPicPr>
+            <a:picLocks noChangeAspect="1"/>
+          </p:cNvPicPr>
+          <p:nvPr/>
+        </p:nvPicPr>
+        <p:blipFill>
+          <a:blip r:embed="rId4"/>
+          <a:stretch>
+            <a:fillRect/>
+          </a:stretch>
+        </p:blipFill>
+        <p:spPr>
+          <a:xfrm>
+            <a:off x="7393125" y="203131"/>
+            <a:ext cx="3352869" cy="1913355"/>
+          </a:xfrm>
+          <a:prstGeom prst="rect">
+            <a:avLst/>
+          </a:prstGeom>
+        </p:spPr>
+      </p:pic>
+      <mc:AlternateContent xmlns:mc="http://schemas.openxmlformats.org/markup-compatibility/2006">
+        <mc:Choice xmlns:p14="http://schemas.microsoft.com/office/powerpoint/2010/main" Requires="p14">
+          <p:contentPart p14:bwMode="auto" r:id="rId5">
+            <p14:nvContentPartPr>
+              <p14:cNvPr id="36" name="Ink 35">
+                <a:extLst>
+                  <a:ext uri="{FF2B5EF4-FFF2-40B4-BE49-F238E27FC236}">
+                    <a16:creationId xmlns:a16="http://schemas.microsoft.com/office/drawing/2014/main" id="{8111E061-2B85-E4FD-2BF3-D44E42931143}"/>
+                  </a:ext>
+                </a:extLst>
+              </p14:cNvPr>
+              <p14:cNvContentPartPr/>
+              <p14:nvPr/>
+            </p14:nvContentPartPr>
+            <p14:xfrm>
+              <a:off x="4259579" y="4324019"/>
+              <a:ext cx="360" cy="2160"/>
+            </p14:xfrm>
+          </p:contentPart>
+        </mc:Choice>
+        <mc:Fallback>
+          <p:pic>
+            <p:nvPicPr>
+              <p:cNvPr id="36" name="Ink 35">
+                <a:extLst>
+                  <a:ext uri="{FF2B5EF4-FFF2-40B4-BE49-F238E27FC236}">
+                    <a16:creationId xmlns:a16="http://schemas.microsoft.com/office/drawing/2014/main" id="{8111E061-2B85-E4FD-2BF3-D44E42931143}"/>
+                  </a:ext>
+                </a:extLst>
+              </p:cNvPr>
+              <p:cNvPicPr/>
+              <p:nvPr/>
+            </p:nvPicPr>
+            <p:blipFill>
+              <a:blip r:embed="rId6"/>
+              <a:stretch>
+                <a:fillRect/>
+              </a:stretch>
+            </p:blipFill>
+            <p:spPr>
+              <a:xfrm>
+                <a:off x="4253459" y="4317899"/>
+                <a:ext cx="12600" cy="14400"/>
+              </a:xfrm>
+              <a:prstGeom prst="rect">
+                <a:avLst/>
+              </a:prstGeom>
+            </p:spPr>
+          </p:pic>
+        </mc:Fallback>
+      </mc:AlternateContent>
+      <p:pic>
+        <p:nvPicPr>
+          <p:cNvPr id="16" name="Picture 15">
+            <a:extLst>
+              <a:ext uri="{FF2B5EF4-FFF2-40B4-BE49-F238E27FC236}">
+                <a16:creationId xmlns:a16="http://schemas.microsoft.com/office/drawing/2014/main" id="{42087267-01C0-EF66-F649-4E38042A858F}"/>
+              </a:ext>
+            </a:extLst>
+          </p:cNvPr>
+          <p:cNvPicPr>
+            <a:picLocks noChangeAspect="1"/>
+          </p:cNvPicPr>
+          <p:nvPr/>
+        </p:nvPicPr>
+        <p:blipFill>
+          <a:blip r:embed="rId7"/>
+          <a:stretch>
+            <a:fillRect/>
+          </a:stretch>
+        </p:blipFill>
+        <p:spPr>
+          <a:xfrm>
+            <a:off x="243840" y="208392"/>
+            <a:ext cx="3326295" cy="1913355"/>
+          </a:xfrm>
+          <a:prstGeom prst="rect">
+            <a:avLst/>
+          </a:prstGeom>
+        </p:spPr>
+      </p:pic>
+      <p:pic>
+        <p:nvPicPr>
+          <p:cNvPr id="18" name="Picture 17">
+            <a:extLst>
+              <a:ext uri="{FF2B5EF4-FFF2-40B4-BE49-F238E27FC236}">
+                <a16:creationId xmlns:a16="http://schemas.microsoft.com/office/drawing/2014/main" id="{67F4A4DB-8A5B-AE01-78B4-78951CF87C27}"/>
+              </a:ext>
+            </a:extLst>
+          </p:cNvPr>
+          <p:cNvPicPr>
+            <a:picLocks noChangeAspect="1"/>
+          </p:cNvPicPr>
+          <p:nvPr/>
+        </p:nvPicPr>
+        <p:blipFill>
+          <a:blip r:embed="rId8"/>
+          <a:stretch>
+            <a:fillRect/>
+          </a:stretch>
+        </p:blipFill>
+        <p:spPr>
+          <a:xfrm>
+            <a:off x="3818482" y="203131"/>
+            <a:ext cx="3326296" cy="1918616"/>
+          </a:xfrm>
+          <a:prstGeom prst="rect">
+            <a:avLst/>
+          </a:prstGeom>
+        </p:spPr>
+      </p:pic>
+      <mc:AlternateContent xmlns:mc="http://schemas.openxmlformats.org/markup-compatibility/2006">
+        <mc:Choice xmlns:p14="http://schemas.microsoft.com/office/powerpoint/2010/main" Requires="p14">
+          <p:contentPart p14:bwMode="auto" r:id="rId9">
+            <p14:nvContentPartPr>
+              <p14:cNvPr id="35" name="Ink 34">
+                <a:extLst>
+                  <a:ext uri="{FF2B5EF4-FFF2-40B4-BE49-F238E27FC236}">
+                    <a16:creationId xmlns:a16="http://schemas.microsoft.com/office/drawing/2014/main" id="{87AB1CA2-D574-2029-B832-69BF3751F2B9}"/>
+                  </a:ext>
+                </a:extLst>
+              </p14:cNvPr>
+              <p14:cNvContentPartPr/>
+              <p14:nvPr/>
+            </p14:nvContentPartPr>
+            <p14:xfrm>
+              <a:off x="2716619" y="2223779"/>
+              <a:ext cx="2160" cy="2160"/>
+            </p14:xfrm>
+          </p:contentPart>
+        </mc:Choice>
+        <mc:Fallback>
+          <p:pic>
+            <p:nvPicPr>
+              <p:cNvPr id="35" name="Ink 34">
+                <a:extLst>
+                  <a:ext uri="{FF2B5EF4-FFF2-40B4-BE49-F238E27FC236}">
+                    <a16:creationId xmlns:a16="http://schemas.microsoft.com/office/drawing/2014/main" id="{87AB1CA2-D574-2029-B832-69BF3751F2B9}"/>
+                  </a:ext>
+                </a:extLst>
+              </p:cNvPr>
+              <p:cNvPicPr/>
+              <p:nvPr/>
+            </p:nvPicPr>
+            <p:blipFill>
+              <a:blip r:embed="rId6"/>
+              <a:stretch>
+                <a:fillRect/>
+              </a:stretch>
+            </p:blipFill>
+            <p:spPr>
+              <a:xfrm>
+                <a:off x="2710499" y="2216435"/>
+                <a:ext cx="14400" cy="16848"/>
+              </a:xfrm>
+              <a:prstGeom prst="rect">
+                <a:avLst/>
+              </a:prstGeom>
+            </p:spPr>
+          </p:pic>
+        </mc:Fallback>
+      </mc:AlternateContent>
+      <p:pic>
+        <p:nvPicPr>
+          <p:cNvPr id="53" name="Picture 52">
+            <a:extLst>
+              <a:ext uri="{FF2B5EF4-FFF2-40B4-BE49-F238E27FC236}">
+                <a16:creationId xmlns:a16="http://schemas.microsoft.com/office/drawing/2014/main" id="{8A5D7095-F77F-30AF-CFE3-9D814F9F0E16}"/>
+              </a:ext>
+            </a:extLst>
+          </p:cNvPr>
+          <p:cNvPicPr>
+            <a:picLocks noChangeAspect="1"/>
+          </p:cNvPicPr>
+          <p:nvPr/>
+        </p:nvPicPr>
+        <p:blipFill>
+          <a:blip r:embed="rId10"/>
+          <a:stretch>
+            <a:fillRect/>
+          </a:stretch>
+        </p:blipFill>
+        <p:spPr>
+          <a:xfrm>
+            <a:off x="9867633" y="3022024"/>
+            <a:ext cx="546131" cy="569126"/>
+          </a:xfrm>
+          <a:prstGeom prst="rect">
+            <a:avLst/>
+          </a:prstGeom>
+        </p:spPr>
+      </p:pic>
+      <p:pic>
+        <p:nvPicPr>
+          <p:cNvPr id="55" name="Picture 54">
+            <a:extLst>
+              <a:ext uri="{FF2B5EF4-FFF2-40B4-BE49-F238E27FC236}">
+                <a16:creationId xmlns:a16="http://schemas.microsoft.com/office/drawing/2014/main" id="{811C8EF9-6ABE-A307-55A5-F68596C2EB2A}"/>
+              </a:ext>
+            </a:extLst>
+          </p:cNvPr>
+          <p:cNvPicPr>
+            <a:picLocks noChangeAspect="1"/>
+          </p:cNvPicPr>
+          <p:nvPr/>
+        </p:nvPicPr>
+        <p:blipFill>
+          <a:blip r:embed="rId11"/>
+          <a:stretch>
+            <a:fillRect/>
+          </a:stretch>
+        </p:blipFill>
+        <p:spPr>
+          <a:xfrm>
+            <a:off x="8806771" y="2505653"/>
+            <a:ext cx="546130" cy="569125"/>
+          </a:xfrm>
+          <a:prstGeom prst="rect">
+            <a:avLst/>
+          </a:prstGeom>
+        </p:spPr>
+      </p:pic>
+      <mc:AlternateContent xmlns:mc="http://schemas.openxmlformats.org/markup-compatibility/2006">
+        <mc:Choice xmlns:p14="http://schemas.microsoft.com/office/powerpoint/2010/main" Requires="p14">
+          <p:contentPart p14:bwMode="auto" r:id="rId12">
+            <p14:nvContentPartPr>
+              <p14:cNvPr id="65" name="Ink 64">
+                <a:extLst>
+                  <a:ext uri="{FF2B5EF4-FFF2-40B4-BE49-F238E27FC236}">
+                    <a16:creationId xmlns:a16="http://schemas.microsoft.com/office/drawing/2014/main" id="{2A2D608C-A465-CA72-E7CF-A87764D8F3A2}"/>
+                  </a:ext>
+                </a:extLst>
+              </p14:cNvPr>
+              <p14:cNvContentPartPr/>
+              <p14:nvPr/>
+            </p14:nvContentPartPr>
+            <p14:xfrm>
+              <a:off x="10130931" y="1550564"/>
+              <a:ext cx="2160" cy="4320"/>
+            </p14:xfrm>
+          </p:contentPart>
+        </mc:Choice>
+        <mc:Fallback>
+          <p:pic>
+            <p:nvPicPr>
+              <p:cNvPr id="65" name="Ink 64">
+                <a:extLst>
+                  <a:ext uri="{FF2B5EF4-FFF2-40B4-BE49-F238E27FC236}">
+                    <a16:creationId xmlns:a16="http://schemas.microsoft.com/office/drawing/2014/main" id="{2A2D608C-A465-CA72-E7CF-A87764D8F3A2}"/>
+                  </a:ext>
+                </a:extLst>
+              </p:cNvPr>
+              <p:cNvPicPr/>
+              <p:nvPr/>
+            </p:nvPicPr>
+            <p:blipFill>
+              <a:blip r:embed="rId13"/>
+              <a:stretch>
+                <a:fillRect/>
+              </a:stretch>
+            </p:blipFill>
+            <p:spPr>
+              <a:xfrm>
+                <a:off x="10124811" y="1543888"/>
+                <a:ext cx="14400" cy="17673"/>
+              </a:xfrm>
+              <a:prstGeom prst="rect">
+                <a:avLst/>
+              </a:prstGeom>
+            </p:spPr>
+          </p:pic>
+        </mc:Fallback>
+      </mc:AlternateContent>
+      <mc:AlternateContent xmlns:mc="http://schemas.openxmlformats.org/markup-compatibility/2006">
+        <mc:Choice xmlns:p14="http://schemas.microsoft.com/office/powerpoint/2010/main" Requires="p14">
+          <p:contentPart p14:bwMode="auto" r:id="rId14">
+            <p14:nvContentPartPr>
+              <p14:cNvPr id="112" name="Ink 111">
+                <a:extLst>
+                  <a:ext uri="{FF2B5EF4-FFF2-40B4-BE49-F238E27FC236}">
+                    <a16:creationId xmlns:a16="http://schemas.microsoft.com/office/drawing/2014/main" id="{CEA9ED46-BD61-6093-C501-EEEEEA353DDF}"/>
+                  </a:ext>
+                </a:extLst>
+              </p14:cNvPr>
+              <p14:cNvContentPartPr/>
+              <p14:nvPr/>
+            </p14:nvContentPartPr>
+            <p14:xfrm>
+              <a:off x="3131936" y="2571794"/>
+              <a:ext cx="1080" cy="1080"/>
+            </p14:xfrm>
+          </p:contentPart>
+        </mc:Choice>
+        <mc:Fallback>
+          <p:pic>
+            <p:nvPicPr>
+              <p:cNvPr id="112" name="Ink 111">
+                <a:extLst>
+                  <a:ext uri="{FF2B5EF4-FFF2-40B4-BE49-F238E27FC236}">
+                    <a16:creationId xmlns:a16="http://schemas.microsoft.com/office/drawing/2014/main" id="{CEA9ED46-BD61-6093-C501-EEEEEA353DDF}"/>
+                  </a:ext>
+                </a:extLst>
+              </p:cNvPr>
+              <p:cNvPicPr/>
+              <p:nvPr/>
+            </p:nvPicPr>
+            <p:blipFill>
+              <a:blip r:embed="rId15"/>
+              <a:stretch>
+                <a:fillRect/>
+              </a:stretch>
+            </p:blipFill>
+            <p:spPr>
+              <a:xfrm>
+                <a:off x="3128696" y="2567474"/>
+                <a:ext cx="7560" cy="9720"/>
+              </a:xfrm>
+              <a:prstGeom prst="rect">
+                <a:avLst/>
+              </a:prstGeom>
+            </p:spPr>
+          </p:pic>
+        </mc:Fallback>
+      </mc:AlternateContent>
+    </p:spTree>
+    <p:extLst>
+      <p:ext uri="{BB962C8B-B14F-4D97-AF65-F5344CB8AC3E}">
+        <p14:creationId xmlns:p14="http://schemas.microsoft.com/office/powerpoint/2010/main" val="2354324109"/>
       </p:ext>
     </p:extLst>
   </p:cSld>

</xml_diff>